<commit_message>
added batch 3 folder
</commit_message>
<xml_diff>
--- a/Presentations/AVR Live Class 10.pptx
+++ b/Presentations/AVR Live Class 10.pptx
@@ -292,351 +292,23 @@
 </p:presentation>
 </file>
 
-<file path=ppt/revisionInfo.xml><?xml version="1.0" encoding="utf-8"?>
-<p1510:revInfo xmlns:a="http://schemas.openxmlformats.org/drawingml/2006/main" xmlns:r="http://schemas.openxmlformats.org/officeDocument/2006/relationships" xmlns:p1510="http://schemas.microsoft.com/office/powerpoint/2015/10/main">
-  <p1510:revLst>
-    <p1510:client id="{1F59BF5F-5FD6-4E83-9AA3-B28647375FF2}" v="21" dt="2025-09-29T14:08:27.753"/>
-  </p1510:revLst>
-</p1510:revInfo>
-</file>
-
 <file path=ppt/changesInfos/changesInfo1.xml><?xml version="1.0" encoding="utf-8"?>
 <pc:chgInfo xmlns:a="http://schemas.openxmlformats.org/drawingml/2006/main" xmlns:r="http://schemas.openxmlformats.org/officeDocument/2006/relationships" xmlns:ac="http://schemas.microsoft.com/office/drawing/2013/main/command" xmlns:pc="http://schemas.microsoft.com/office/powerpoint/2013/main/command">
   <pc:docChgLst>
     <pc:chgData name="Sreejith Rajan" userId="ec11bca0e4bee75f" providerId="LiveId" clId="{7B4F392D-EAB3-4CE7-903E-F84869825F47}"/>
     <pc:docChg chg="undo custSel addSld delSld modSld sldOrd">
-      <pc:chgData name="Sreejith Rajan" userId="ec11bca0e4bee75f" providerId="LiveId" clId="{7B4F392D-EAB3-4CE7-903E-F84869825F47}" dt="2025-09-29T14:14:41.011" v="3038" actId="478"/>
+      <pc:chgData name="Sreejith Rajan" userId="ec11bca0e4bee75f" providerId="LiveId" clId="{7B4F392D-EAB3-4CE7-903E-F84869825F47}" dt="2025-12-04T14:51:52.436" v="3039" actId="20577"/>
       <pc:docMkLst>
         <pc:docMk/>
       </pc:docMkLst>
-      <pc:sldChg chg="modSp mod">
-        <pc:chgData name="Sreejith Rajan" userId="ec11bca0e4bee75f" providerId="LiveId" clId="{7B4F392D-EAB3-4CE7-903E-F84869825F47}" dt="2025-09-29T12:54:05.082" v="2158" actId="20577"/>
-        <pc:sldMkLst>
-          <pc:docMk/>
-          <pc:sldMk cId="0" sldId="256"/>
-        </pc:sldMkLst>
-        <pc:spChg chg="mod">
-          <ac:chgData name="Sreejith Rajan" userId="ec11bca0e4bee75f" providerId="LiveId" clId="{7B4F392D-EAB3-4CE7-903E-F84869825F47}" dt="2025-09-29T12:54:05.082" v="2158" actId="20577"/>
-          <ac:spMkLst>
-            <pc:docMk/>
-            <pc:sldMk cId="0" sldId="256"/>
-            <ac:spMk id="33" creationId="{00000000-0000-0000-0000-000000000000}"/>
-          </ac:spMkLst>
-        </pc:spChg>
-      </pc:sldChg>
-      <pc:sldChg chg="addSp modSp del mod">
-        <pc:chgData name="Sreejith Rajan" userId="ec11bca0e4bee75f" providerId="LiveId" clId="{7B4F392D-EAB3-4CE7-903E-F84869825F47}" dt="2025-09-26T13:36:34.936" v="1819" actId="47"/>
-        <pc:sldMkLst>
-          <pc:docMk/>
-          <pc:sldMk cId="0" sldId="258"/>
-        </pc:sldMkLst>
-      </pc:sldChg>
-      <pc:sldChg chg="addSp delSp modSp add del mod ord">
-        <pc:chgData name="Sreejith Rajan" userId="ec11bca0e4bee75f" providerId="LiveId" clId="{7B4F392D-EAB3-4CE7-903E-F84869825F47}" dt="2025-09-26T13:36:37.995" v="1822" actId="47"/>
-        <pc:sldMkLst>
-          <pc:docMk/>
-          <pc:sldMk cId="1389626550" sldId="267"/>
-        </pc:sldMkLst>
-      </pc:sldChg>
-      <pc:sldChg chg="addSp delSp modSp del mod">
-        <pc:chgData name="Sreejith Rajan" userId="ec11bca0e4bee75f" providerId="LiveId" clId="{7B4F392D-EAB3-4CE7-903E-F84869825F47}" dt="2025-09-29T13:47:37.003" v="2823" actId="2696"/>
-        <pc:sldMkLst>
-          <pc:docMk/>
-          <pc:sldMk cId="2517281589" sldId="274"/>
-        </pc:sldMkLst>
-        <pc:spChg chg="add del">
-          <ac:chgData name="Sreejith Rajan" userId="ec11bca0e4bee75f" providerId="LiveId" clId="{7B4F392D-EAB3-4CE7-903E-F84869825F47}" dt="2025-09-29T12:54:40.949" v="2167" actId="22"/>
-          <ac:spMkLst>
-            <pc:docMk/>
-            <pc:sldMk cId="2517281589" sldId="274"/>
-            <ac:spMk id="4" creationId="{F7A82D54-3B55-A924-E54D-CE3243A0E764}"/>
-          </ac:spMkLst>
-        </pc:spChg>
-        <pc:spChg chg="del mod">
-          <ac:chgData name="Sreejith Rajan" userId="ec11bca0e4bee75f" providerId="LiveId" clId="{7B4F392D-EAB3-4CE7-903E-F84869825F47}" dt="2025-09-29T12:54:19.816" v="2162" actId="478"/>
-          <ac:spMkLst>
-            <pc:docMk/>
-            <pc:sldMk cId="2517281589" sldId="274"/>
-            <ac:spMk id="54" creationId="{F5C408E8-BC47-B2C2-7462-C129AFFB4F4F}"/>
-          </ac:spMkLst>
-        </pc:spChg>
-        <pc:graphicFrameChg chg="add mod">
-          <ac:chgData name="Sreejith Rajan" userId="ec11bca0e4bee75f" providerId="LiveId" clId="{7B4F392D-EAB3-4CE7-903E-F84869825F47}" dt="2025-09-29T12:54:26.093" v="2164"/>
-          <ac:graphicFrameMkLst>
-            <pc:docMk/>
-            <pc:sldMk cId="2517281589" sldId="274"/>
-            <ac:graphicFrameMk id="2" creationId="{969027AF-E278-C108-FC66-720A72D3F34B}"/>
-          </ac:graphicFrameMkLst>
-        </pc:graphicFrameChg>
-      </pc:sldChg>
-      <pc:sldChg chg="modSp del mod ord">
-        <pc:chgData name="Sreejith Rajan" userId="ec11bca0e4bee75f" providerId="LiveId" clId="{7B4F392D-EAB3-4CE7-903E-F84869825F47}" dt="2025-09-26T13:36:34.298" v="1818" actId="47"/>
-        <pc:sldMkLst>
-          <pc:docMk/>
-          <pc:sldMk cId="682396941" sldId="282"/>
-        </pc:sldMkLst>
-      </pc:sldChg>
-      <pc:sldChg chg="addSp modSp del mod ord">
-        <pc:chgData name="Sreejith Rajan" userId="ec11bca0e4bee75f" providerId="LiveId" clId="{7B4F392D-EAB3-4CE7-903E-F84869825F47}" dt="2025-09-26T13:36:36.779" v="1821" actId="47"/>
-        <pc:sldMkLst>
-          <pc:docMk/>
-          <pc:sldMk cId="3362503428" sldId="283"/>
-        </pc:sldMkLst>
-      </pc:sldChg>
-      <pc:sldChg chg="addSp delSp modSp del mod">
-        <pc:chgData name="Sreejith Rajan" userId="ec11bca0e4bee75f" providerId="LiveId" clId="{7B4F392D-EAB3-4CE7-903E-F84869825F47}" dt="2025-09-26T13:36:35.786" v="1820" actId="47"/>
-        <pc:sldMkLst>
-          <pc:docMk/>
-          <pc:sldMk cId="2771709912" sldId="285"/>
-        </pc:sldMkLst>
-      </pc:sldChg>
-      <pc:sldChg chg="delSp del mod">
-        <pc:chgData name="Sreejith Rajan" userId="ec11bca0e4bee75f" providerId="LiveId" clId="{7B4F392D-EAB3-4CE7-903E-F84869825F47}" dt="2025-09-19T08:54:52.742" v="755" actId="47"/>
-        <pc:sldMkLst>
-          <pc:docMk/>
-          <pc:sldMk cId="321485736" sldId="286"/>
-        </pc:sldMkLst>
-      </pc:sldChg>
-      <pc:sldChg chg="modSp mod">
-        <pc:chgData name="Sreejith Rajan" userId="ec11bca0e4bee75f" providerId="LiveId" clId="{7B4F392D-EAB3-4CE7-903E-F84869825F47}" dt="2025-09-29T13:12:02.614" v="2183" actId="1076"/>
-        <pc:sldMkLst>
-          <pc:docMk/>
-          <pc:sldMk cId="3959199433" sldId="287"/>
-        </pc:sldMkLst>
-        <pc:spChg chg="mod">
-          <ac:chgData name="Sreejith Rajan" userId="ec11bca0e4bee75f" providerId="LiveId" clId="{7B4F392D-EAB3-4CE7-903E-F84869825F47}" dt="2025-09-29T13:10:14.515" v="2177" actId="20577"/>
-          <ac:spMkLst>
-            <pc:docMk/>
-            <pc:sldMk cId="3959199433" sldId="287"/>
-            <ac:spMk id="54" creationId="{C4CE2FAD-1A13-21FB-4CDB-D7E0702E4157}"/>
-          </ac:spMkLst>
-        </pc:spChg>
-        <pc:spChg chg="mod">
-          <ac:chgData name="Sreejith Rajan" userId="ec11bca0e4bee75f" providerId="LiveId" clId="{7B4F392D-EAB3-4CE7-903E-F84869825F47}" dt="2025-09-29T13:12:02.614" v="2183" actId="1076"/>
-          <ac:spMkLst>
-            <pc:docMk/>
-            <pc:sldMk cId="3959199433" sldId="287"/>
-            <ac:spMk id="55" creationId="{FF1E4D12-E5A8-7B19-694A-8370FEB4E421}"/>
-          </ac:spMkLst>
-        </pc:spChg>
-      </pc:sldChg>
-      <pc:sldChg chg="del">
-        <pc:chgData name="Sreejith Rajan" userId="ec11bca0e4bee75f" providerId="LiveId" clId="{7B4F392D-EAB3-4CE7-903E-F84869825F47}" dt="2025-09-19T09:13:31.674" v="1068" actId="47"/>
-        <pc:sldMkLst>
-          <pc:docMk/>
-          <pc:sldMk cId="1933302962" sldId="288"/>
-        </pc:sldMkLst>
-      </pc:sldChg>
-      <pc:sldChg chg="del">
-        <pc:chgData name="Sreejith Rajan" userId="ec11bca0e4bee75f" providerId="LiveId" clId="{7B4F392D-EAB3-4CE7-903E-F84869825F47}" dt="2025-09-19T09:13:25.785" v="1067" actId="47"/>
-        <pc:sldMkLst>
-          <pc:docMk/>
-          <pc:sldMk cId="1380718396" sldId="289"/>
-        </pc:sldMkLst>
-      </pc:sldChg>
-      <pc:sldChg chg="addSp delSp modSp add del mod">
-        <pc:chgData name="Sreejith Rajan" userId="ec11bca0e4bee75f" providerId="LiveId" clId="{7B4F392D-EAB3-4CE7-903E-F84869825F47}" dt="2025-09-26T13:36:40.310" v="1825" actId="47"/>
-        <pc:sldMkLst>
-          <pc:docMk/>
-          <pc:sldMk cId="4163967858" sldId="290"/>
-        </pc:sldMkLst>
-      </pc:sldChg>
-      <pc:sldChg chg="delSp modSp add del mod">
-        <pc:chgData name="Sreejith Rajan" userId="ec11bca0e4bee75f" providerId="LiveId" clId="{7B4F392D-EAB3-4CE7-903E-F84869825F47}" dt="2025-09-26T13:36:39.459" v="1824" actId="47"/>
-        <pc:sldMkLst>
-          <pc:docMk/>
-          <pc:sldMk cId="3054169711" sldId="291"/>
-        </pc:sldMkLst>
-      </pc:sldChg>
-      <pc:sldChg chg="addSp modSp add mod">
-        <pc:chgData name="Sreejith Rajan" userId="ec11bca0e4bee75f" providerId="LiveId" clId="{7B4F392D-EAB3-4CE7-903E-F84869825F47}" dt="2025-09-29T13:18:42.747" v="2370" actId="20577"/>
-        <pc:sldMkLst>
-          <pc:docMk/>
-          <pc:sldMk cId="1690133944" sldId="292"/>
-        </pc:sldMkLst>
-        <pc:spChg chg="mod">
-          <ac:chgData name="Sreejith Rajan" userId="ec11bca0e4bee75f" providerId="LiveId" clId="{7B4F392D-EAB3-4CE7-903E-F84869825F47}" dt="2025-09-29T13:12:20.061" v="2215" actId="20577"/>
-          <ac:spMkLst>
-            <pc:docMk/>
-            <pc:sldMk cId="1690133944" sldId="292"/>
-            <ac:spMk id="54" creationId="{EDC9C741-9EF9-AD1A-B10B-C0F0FD0E5589}"/>
-          </ac:spMkLst>
-        </pc:spChg>
-        <pc:spChg chg="mod">
-          <ac:chgData name="Sreejith Rajan" userId="ec11bca0e4bee75f" providerId="LiveId" clId="{7B4F392D-EAB3-4CE7-903E-F84869825F47}" dt="2025-09-29T13:18:42.747" v="2370" actId="20577"/>
-          <ac:spMkLst>
-            <pc:docMk/>
-            <pc:sldMk cId="1690133944" sldId="292"/>
-            <ac:spMk id="55" creationId="{26607F08-7416-A9D7-E979-6607C70A9BA6}"/>
-          </ac:spMkLst>
-        </pc:spChg>
-      </pc:sldChg>
-      <pc:sldChg chg="delSp modSp add del mod ord">
-        <pc:chgData name="Sreejith Rajan" userId="ec11bca0e4bee75f" providerId="LiveId" clId="{7B4F392D-EAB3-4CE7-903E-F84869825F47}" dt="2025-09-26T13:36:33.418" v="1817" actId="47"/>
-        <pc:sldMkLst>
-          <pc:docMk/>
-          <pc:sldMk cId="1886088078" sldId="293"/>
-        </pc:sldMkLst>
-      </pc:sldChg>
       <pc:sldChg chg="modSp add mod">
-        <pc:chgData name="Sreejith Rajan" userId="ec11bca0e4bee75f" providerId="LiveId" clId="{7B4F392D-EAB3-4CE7-903E-F84869825F47}" dt="2025-09-29T13:27:27.215" v="2393" actId="15"/>
-        <pc:sldMkLst>
-          <pc:docMk/>
-          <pc:sldMk cId="3780731234" sldId="293"/>
-        </pc:sldMkLst>
-        <pc:spChg chg="mod">
-          <ac:chgData name="Sreejith Rajan" userId="ec11bca0e4bee75f" providerId="LiveId" clId="{7B4F392D-EAB3-4CE7-903E-F84869825F47}" dt="2025-09-29T13:25:49.913" v="2373"/>
-          <ac:spMkLst>
-            <pc:docMk/>
-            <pc:sldMk cId="3780731234" sldId="293"/>
-            <ac:spMk id="54" creationId="{60F6E915-346F-0648-5434-0DE850C1C3AB}"/>
-          </ac:spMkLst>
-        </pc:spChg>
-        <pc:spChg chg="mod">
-          <ac:chgData name="Sreejith Rajan" userId="ec11bca0e4bee75f" providerId="LiveId" clId="{7B4F392D-EAB3-4CE7-903E-F84869825F47}" dt="2025-09-29T13:27:27.215" v="2393" actId="15"/>
-          <ac:spMkLst>
-            <pc:docMk/>
-            <pc:sldMk cId="3780731234" sldId="293"/>
-            <ac:spMk id="55" creationId="{91E121BF-B148-C323-2C17-57532AC62F17}"/>
-          </ac:spMkLst>
-        </pc:spChg>
-      </pc:sldChg>
-      <pc:sldChg chg="addSp delSp modSp add del mod">
-        <pc:chgData name="Sreejith Rajan" userId="ec11bca0e4bee75f" providerId="LiveId" clId="{7B4F392D-EAB3-4CE7-903E-F84869825F47}" dt="2025-09-26T13:36:38.704" v="1823" actId="47"/>
-        <pc:sldMkLst>
-          <pc:docMk/>
-          <pc:sldMk cId="812141662" sldId="294"/>
-        </pc:sldMkLst>
-      </pc:sldChg>
-      <pc:sldChg chg="modSp add mod">
-        <pc:chgData name="Sreejith Rajan" userId="ec11bca0e4bee75f" providerId="LiveId" clId="{7B4F392D-EAB3-4CE7-903E-F84869825F47}" dt="2025-09-29T13:15:01.260" v="2242" actId="20577"/>
-        <pc:sldMkLst>
-          <pc:docMk/>
-          <pc:sldMk cId="2315289045" sldId="294"/>
-        </pc:sldMkLst>
-        <pc:spChg chg="mod">
-          <ac:chgData name="Sreejith Rajan" userId="ec11bca0e4bee75f" providerId="LiveId" clId="{7B4F392D-EAB3-4CE7-903E-F84869825F47}" dt="2025-09-29T13:15:01.260" v="2242" actId="20577"/>
-          <ac:spMkLst>
-            <pc:docMk/>
-            <pc:sldMk cId="2315289045" sldId="294"/>
-            <ac:spMk id="55" creationId="{FF113802-DA28-7907-6E53-38E3245C4292}"/>
-          </ac:spMkLst>
-        </pc:spChg>
-      </pc:sldChg>
-      <pc:sldChg chg="new del">
-        <pc:chgData name="Sreejith Rajan" userId="ec11bca0e4bee75f" providerId="LiveId" clId="{7B4F392D-EAB3-4CE7-903E-F84869825F47}" dt="2025-09-19T09:29:05.345" v="1574" actId="680"/>
-        <pc:sldMkLst>
-          <pc:docMk/>
-          <pc:sldMk cId="4185100054" sldId="294"/>
-        </pc:sldMkLst>
-      </pc:sldChg>
-      <pc:sldChg chg="modSp add mod">
-        <pc:chgData name="Sreejith Rajan" userId="ec11bca0e4bee75f" providerId="LiveId" clId="{7B4F392D-EAB3-4CE7-903E-F84869825F47}" dt="2025-09-29T13:16:58.895" v="2300" actId="20577"/>
-        <pc:sldMkLst>
-          <pc:docMk/>
-          <pc:sldMk cId="61760651" sldId="295"/>
-        </pc:sldMkLst>
-        <pc:spChg chg="mod">
-          <ac:chgData name="Sreejith Rajan" userId="ec11bca0e4bee75f" providerId="LiveId" clId="{7B4F392D-EAB3-4CE7-903E-F84869825F47}" dt="2025-09-29T13:16:58.895" v="2300" actId="20577"/>
-          <ac:spMkLst>
-            <pc:docMk/>
-            <pc:sldMk cId="61760651" sldId="295"/>
-            <ac:spMk id="55" creationId="{C4EED2E4-4A8C-D745-8F26-A0147358438C}"/>
-          </ac:spMkLst>
-        </pc:spChg>
-      </pc:sldChg>
-      <pc:sldChg chg="delSp modSp add mod">
-        <pc:chgData name="Sreejith Rajan" userId="ec11bca0e4bee75f" providerId="LiveId" clId="{7B4F392D-EAB3-4CE7-903E-F84869825F47}" dt="2025-09-29T14:13:41.212" v="3035" actId="478"/>
-        <pc:sldMkLst>
-          <pc:docMk/>
-          <pc:sldMk cId="1080415345" sldId="296"/>
-        </pc:sldMkLst>
-        <pc:spChg chg="del">
-          <ac:chgData name="Sreejith Rajan" userId="ec11bca0e4bee75f" providerId="LiveId" clId="{7B4F392D-EAB3-4CE7-903E-F84869825F47}" dt="2025-09-29T14:13:41.212" v="3035" actId="478"/>
-          <ac:spMkLst>
-            <pc:docMk/>
-            <pc:sldMk cId="1080415345" sldId="296"/>
-            <ac:spMk id="7" creationId="{231AF83F-979B-45ED-6B55-0CB9F377465B}"/>
-          </ac:spMkLst>
-        </pc:spChg>
-        <pc:spChg chg="mod">
-          <ac:chgData name="Sreejith Rajan" userId="ec11bca0e4bee75f" providerId="LiveId" clId="{7B4F392D-EAB3-4CE7-903E-F84869825F47}" dt="2025-09-29T13:19:02.642" v="2372" actId="20577"/>
-          <ac:spMkLst>
-            <pc:docMk/>
-            <pc:sldMk cId="1080415345" sldId="296"/>
-            <ac:spMk id="55" creationId="{C728937B-B3AC-3FDB-89F0-2EA70D8FF5EA}"/>
-          </ac:spMkLst>
-        </pc:spChg>
-      </pc:sldChg>
-      <pc:sldChg chg="modSp add mod">
-        <pc:chgData name="Sreejith Rajan" userId="ec11bca0e4bee75f" providerId="LiveId" clId="{7B4F392D-EAB3-4CE7-903E-F84869825F47}" dt="2025-09-29T13:28:23.116" v="2401" actId="5793"/>
-        <pc:sldMkLst>
-          <pc:docMk/>
-          <pc:sldMk cId="2067657878" sldId="297"/>
-        </pc:sldMkLst>
-        <pc:spChg chg="mod">
-          <ac:chgData name="Sreejith Rajan" userId="ec11bca0e4bee75f" providerId="LiveId" clId="{7B4F392D-EAB3-4CE7-903E-F84869825F47}" dt="2025-09-29T13:28:23.116" v="2401" actId="5793"/>
-          <ac:spMkLst>
-            <pc:docMk/>
-            <pc:sldMk cId="2067657878" sldId="297"/>
-            <ac:spMk id="55" creationId="{5C6ED6F9-600A-BA4D-CB97-78CEEEFAF9BB}"/>
-          </ac:spMkLst>
-        </pc:spChg>
-      </pc:sldChg>
-      <pc:sldChg chg="delSp modSp add mod">
-        <pc:chgData name="Sreejith Rajan" userId="ec11bca0e4bee75f" providerId="LiveId" clId="{7B4F392D-EAB3-4CE7-903E-F84869825F47}" dt="2025-09-29T14:14:41.011" v="3038" actId="478"/>
-        <pc:sldMkLst>
-          <pc:docMk/>
-          <pc:sldMk cId="2603797813" sldId="298"/>
-        </pc:sldMkLst>
-        <pc:spChg chg="del">
-          <ac:chgData name="Sreejith Rajan" userId="ec11bca0e4bee75f" providerId="LiveId" clId="{7B4F392D-EAB3-4CE7-903E-F84869825F47}" dt="2025-09-29T14:14:41.011" v="3038" actId="478"/>
-          <ac:spMkLst>
-            <pc:docMk/>
-            <pc:sldMk cId="2603797813" sldId="298"/>
-            <ac:spMk id="7" creationId="{EC233DC1-8E8E-27BA-D90E-5E814ED4298B}"/>
-          </ac:spMkLst>
-        </pc:spChg>
-        <pc:spChg chg="mod">
-          <ac:chgData name="Sreejith Rajan" userId="ec11bca0e4bee75f" providerId="LiveId" clId="{7B4F392D-EAB3-4CE7-903E-F84869825F47}" dt="2025-09-29T13:29:46.649" v="2415" actId="20577"/>
-          <ac:spMkLst>
-            <pc:docMk/>
-            <pc:sldMk cId="2603797813" sldId="298"/>
-            <ac:spMk id="55" creationId="{C37BE719-C96B-E722-B0C7-DB6DB56C2103}"/>
-          </ac:spMkLst>
-        </pc:spChg>
-      </pc:sldChg>
-      <pc:sldChg chg="modSp add">
-        <pc:chgData name="Sreejith Rajan" userId="ec11bca0e4bee75f" providerId="LiveId" clId="{7B4F392D-EAB3-4CE7-903E-F84869825F47}" dt="2025-09-29T13:29:59.453" v="2417"/>
-        <pc:sldMkLst>
-          <pc:docMk/>
-          <pc:sldMk cId="1429475194" sldId="299"/>
-        </pc:sldMkLst>
-        <pc:spChg chg="mod">
-          <ac:chgData name="Sreejith Rajan" userId="ec11bca0e4bee75f" providerId="LiveId" clId="{7B4F392D-EAB3-4CE7-903E-F84869825F47}" dt="2025-09-29T13:29:59.453" v="2417"/>
-          <ac:spMkLst>
-            <pc:docMk/>
-            <pc:sldMk cId="1429475194" sldId="299"/>
-            <ac:spMk id="55" creationId="{ECEA18D3-E35E-6AD1-D8A2-A19DE71A28DC}"/>
-          </ac:spMkLst>
-        </pc:spChg>
-      </pc:sldChg>
-      <pc:sldChg chg="modSp add mod">
-        <pc:chgData name="Sreejith Rajan" userId="ec11bca0e4bee75f" providerId="LiveId" clId="{7B4F392D-EAB3-4CE7-903E-F84869825F47}" dt="2025-09-29T14:14:02.987" v="3037" actId="207"/>
+        <pc:chgData name="Sreejith Rajan" userId="ec11bca0e4bee75f" providerId="LiveId" clId="{7B4F392D-EAB3-4CE7-903E-F84869825F47}" dt="2025-12-04T14:51:52.436" v="3039" actId="20577"/>
         <pc:sldMkLst>
           <pc:docMk/>
           <pc:sldMk cId="2943669043" sldId="300"/>
         </pc:sldMkLst>
         <pc:spChg chg="mod">
-          <ac:chgData name="Sreejith Rajan" userId="ec11bca0e4bee75f" providerId="LiveId" clId="{7B4F392D-EAB3-4CE7-903E-F84869825F47}" dt="2025-09-29T13:30:52.004" v="2440" actId="20577"/>
-          <ac:spMkLst>
-            <pc:docMk/>
-            <pc:sldMk cId="2943669043" sldId="300"/>
-            <ac:spMk id="54" creationId="{669C9BC1-D42B-10BD-262B-BBC8E4E6D85D}"/>
-          </ac:spMkLst>
-        </pc:spChg>
-        <pc:spChg chg="mod">
-          <ac:chgData name="Sreejith Rajan" userId="ec11bca0e4bee75f" providerId="LiveId" clId="{7B4F392D-EAB3-4CE7-903E-F84869825F47}" dt="2025-09-29T14:14:02.987" v="3037" actId="207"/>
+          <ac:chgData name="Sreejith Rajan" userId="ec11bca0e4bee75f" providerId="LiveId" clId="{7B4F392D-EAB3-4CE7-903E-F84869825F47}" dt="2025-12-04T14:51:52.436" v="3039" actId="20577"/>
           <ac:spMkLst>
             <pc:docMk/>
             <pc:sldMk cId="2943669043" sldId="300"/>
@@ -644,115 +316,6 @@
           </ac:spMkLst>
         </pc:spChg>
       </pc:sldChg>
-      <pc:sldChg chg="addSp delSp modSp new mod">
-        <pc:chgData name="Sreejith Rajan" userId="ec11bca0e4bee75f" providerId="LiveId" clId="{7B4F392D-EAB3-4CE7-903E-F84869825F47}" dt="2025-09-29T13:49:56.969" v="2890" actId="207"/>
-        <pc:sldMkLst>
-          <pc:docMk/>
-          <pc:sldMk cId="3650779004" sldId="301"/>
-        </pc:sldMkLst>
-        <pc:spChg chg="del mod">
-          <ac:chgData name="Sreejith Rajan" userId="ec11bca0e4bee75f" providerId="LiveId" clId="{7B4F392D-EAB3-4CE7-903E-F84869825F47}" dt="2025-09-29T13:49:47.674" v="2888" actId="478"/>
-          <ac:spMkLst>
-            <pc:docMk/>
-            <pc:sldMk cId="3650779004" sldId="301"/>
-            <ac:spMk id="2" creationId="{95EA12A0-15C8-2338-C513-10DE18B70038}"/>
-          </ac:spMkLst>
-        </pc:spChg>
-        <pc:spChg chg="mod">
-          <ac:chgData name="Sreejith Rajan" userId="ec11bca0e4bee75f" providerId="LiveId" clId="{7B4F392D-EAB3-4CE7-903E-F84869825F47}" dt="2025-09-29T13:48:13.603" v="2879" actId="1076"/>
-          <ac:spMkLst>
-            <pc:docMk/>
-            <pc:sldMk cId="3650779004" sldId="301"/>
-            <ac:spMk id="3" creationId="{E22ECBCE-667D-DE83-1959-2E0B8DC7D2F9}"/>
-          </ac:spMkLst>
-        </pc:spChg>
-        <pc:graphicFrameChg chg="add mod modGraphic">
-          <ac:chgData name="Sreejith Rajan" userId="ec11bca0e4bee75f" providerId="LiveId" clId="{7B4F392D-EAB3-4CE7-903E-F84869825F47}" dt="2025-09-29T13:49:56.969" v="2890" actId="207"/>
-          <ac:graphicFrameMkLst>
-            <pc:docMk/>
-            <pc:sldMk cId="3650779004" sldId="301"/>
-            <ac:graphicFrameMk id="6" creationId="{F913DC9A-5FF0-1184-E41C-4486A6A088EF}"/>
-          </ac:graphicFrameMkLst>
-        </pc:graphicFrameChg>
-        <pc:picChg chg="add mod">
-          <ac:chgData name="Sreejith Rajan" userId="ec11bca0e4bee75f" providerId="LiveId" clId="{7B4F392D-EAB3-4CE7-903E-F84869825F47}" dt="2025-09-29T13:49:33.330" v="2886" actId="1076"/>
-          <ac:picMkLst>
-            <pc:docMk/>
-            <pc:sldMk cId="3650779004" sldId="301"/>
-            <ac:picMk id="5" creationId="{7821CB23-8C58-8DDF-6A8E-5713F9211F3E}"/>
-          </ac:picMkLst>
-        </pc:picChg>
-      </pc:sldChg>
-      <pc:sldChg chg="addSp delSp modSp add mod">
-        <pc:chgData name="Sreejith Rajan" userId="ec11bca0e4bee75f" providerId="LiveId" clId="{7B4F392D-EAB3-4CE7-903E-F84869825F47}" dt="2025-09-29T14:11:04.866" v="3034" actId="1076"/>
-        <pc:sldMkLst>
-          <pc:docMk/>
-          <pc:sldMk cId="3714944730" sldId="302"/>
-        </pc:sldMkLst>
-        <pc:spChg chg="mod">
-          <ac:chgData name="Sreejith Rajan" userId="ec11bca0e4bee75f" providerId="LiveId" clId="{7B4F392D-EAB3-4CE7-903E-F84869825F47}" dt="2025-09-29T14:07:15.617" v="2939" actId="20577"/>
-          <ac:spMkLst>
-            <pc:docMk/>
-            <pc:sldMk cId="3714944730" sldId="302"/>
-            <ac:spMk id="3" creationId="{9A5E973B-5344-4C6D-12DD-F7CC77451F61}"/>
-          </ac:spMkLst>
-        </pc:spChg>
-        <pc:spChg chg="add del mod">
-          <ac:chgData name="Sreejith Rajan" userId="ec11bca0e4bee75f" providerId="LiveId" clId="{7B4F392D-EAB3-4CE7-903E-F84869825F47}" dt="2025-09-29T14:08:19.470" v="2951"/>
-          <ac:spMkLst>
-            <pc:docMk/>
-            <pc:sldMk cId="3714944730" sldId="302"/>
-            <ac:spMk id="7" creationId="{FED5BE13-8467-B75A-1229-821E95E27946}"/>
-          </ac:spMkLst>
-        </pc:spChg>
-        <pc:spChg chg="add mod">
-          <ac:chgData name="Sreejith Rajan" userId="ec11bca0e4bee75f" providerId="LiveId" clId="{7B4F392D-EAB3-4CE7-903E-F84869825F47}" dt="2025-09-29T14:10:59.223" v="3033" actId="20577"/>
-          <ac:spMkLst>
-            <pc:docMk/>
-            <pc:sldMk cId="3714944730" sldId="302"/>
-            <ac:spMk id="8" creationId="{21DAB97F-2227-4E0D-98E7-FC9118B74F61}"/>
-          </ac:spMkLst>
-        </pc:spChg>
-        <pc:graphicFrameChg chg="del">
-          <ac:chgData name="Sreejith Rajan" userId="ec11bca0e4bee75f" providerId="LiveId" clId="{7B4F392D-EAB3-4CE7-903E-F84869825F47}" dt="2025-09-29T14:07:59.286" v="2946" actId="21"/>
-          <ac:graphicFrameMkLst>
-            <pc:docMk/>
-            <pc:sldMk cId="3714944730" sldId="302"/>
-            <ac:graphicFrameMk id="6" creationId="{8A4C0407-F42C-0617-C7EA-12D1C45621DD}"/>
-          </ac:graphicFrameMkLst>
-        </pc:graphicFrameChg>
-        <pc:picChg chg="add mod">
-          <ac:chgData name="Sreejith Rajan" userId="ec11bca0e4bee75f" providerId="LiveId" clId="{7B4F392D-EAB3-4CE7-903E-F84869825F47}" dt="2025-09-29T14:11:04.866" v="3034" actId="1076"/>
-          <ac:picMkLst>
-            <pc:docMk/>
-            <pc:sldMk cId="3714944730" sldId="302"/>
-            <ac:picMk id="4" creationId="{23BBE327-DC88-43C5-C721-2EAFCE6DC1FC}"/>
-          </ac:picMkLst>
-        </pc:picChg>
-        <pc:picChg chg="del">
-          <ac:chgData name="Sreejith Rajan" userId="ec11bca0e4bee75f" providerId="LiveId" clId="{7B4F392D-EAB3-4CE7-903E-F84869825F47}" dt="2025-09-29T14:07:17.780" v="2940" actId="478"/>
-          <ac:picMkLst>
-            <pc:docMk/>
-            <pc:sldMk cId="3714944730" sldId="302"/>
-            <ac:picMk id="5" creationId="{081630B0-48DA-8765-C991-B7F4700903FD}"/>
-          </ac:picMkLst>
-        </pc:picChg>
-      </pc:sldChg>
-      <pc:sldMasterChg chg="delSldLayout">
-        <pc:chgData name="Sreejith Rajan" userId="ec11bca0e4bee75f" providerId="LiveId" clId="{7B4F392D-EAB3-4CE7-903E-F84869825F47}" dt="2025-09-26T13:36:35.786" v="1820" actId="47"/>
-        <pc:sldMasterMkLst>
-          <pc:docMk/>
-          <pc:sldMasterMk cId="0" sldId="2147483654"/>
-        </pc:sldMasterMkLst>
-        <pc:sldLayoutChg chg="del">
-          <pc:chgData name="Sreejith Rajan" userId="ec11bca0e4bee75f" providerId="LiveId" clId="{7B4F392D-EAB3-4CE7-903E-F84869825F47}" dt="2025-09-26T13:36:35.786" v="1820" actId="47"/>
-          <pc:sldLayoutMkLst>
-            <pc:docMk/>
-            <pc:sldMasterMk cId="0" sldId="2147483654"/>
-            <pc:sldLayoutMk cId="0" sldId="2147483649"/>
-          </pc:sldLayoutMkLst>
-        </pc:sldLayoutChg>
-      </pc:sldMasterChg>
     </pc:docChg>
   </pc:docChgLst>
 </pc:chgInfo>
@@ -7764,8 +7327,12 @@
           <a:lstStyle/>
           <a:p>
             <a:r>
+              <a:rPr lang="en-US" b="1"/>
+              <a:t>Program </a:t>
+            </a:r>
+            <a:r>
               <a:rPr lang="en-US" b="1" dirty="0"/>
-              <a:t>Programs is running normally</a:t>
+              <a:t>is running normally</a:t>
             </a:r>
           </a:p>
           <a:p>

</xml_diff>